<commit_message>
Resolve merge conflict by keeping local changes
</commit_message>
<xml_diff>
--- a/Sonic_Sommelier_Progress_Update.pptx
+++ b/Sonic_Sommelier_Progress_Update.pptx
@@ -314,7 +314,7 @@
             <a:fld id="{8ACDB3CC-F982-40F9-8DD6-BCC9AFBF44BD}" type="datetime1">
               <a:rPr lang="en-US" smtClean="0"/>
               <a:pPr/>
-              <a:t>6/25/2026</a:t>
+              <a:t>6/26/2026</a:t>
             </a:fld>
             <a:endParaRPr lang="en-US" dirty="0"/>
           </a:p>
@@ -547,7 +547,7 @@
           <a:p>
             <a:fld id="{68C2560D-EC28-3B41-86E8-18F1CE0113B4}" type="datetimeFigureOut">
               <a:rPr lang="en-US" smtClean="0"/>
-              <a:t>6/25/2026</a:t>
+              <a:t>6/26/2026</a:t>
             </a:fld>
             <a:endParaRPr lang="en-US"/>
           </a:p>
@@ -696,7 +696,7 @@
           <a:p>
             <a:fld id="{68C2560D-EC28-3B41-86E8-18F1CE0113B4}" type="datetimeFigureOut">
               <a:rPr lang="en-US" smtClean="0"/>
-              <a:t>6/25/2026</a:t>
+              <a:t>6/26/2026</a:t>
             </a:fld>
             <a:endParaRPr lang="en-US"/>
           </a:p>
@@ -882,7 +882,7 @@
           <a:p>
             <a:fld id="{68C2560D-EC28-3B41-86E8-18F1CE0113B4}" type="datetimeFigureOut">
               <a:rPr lang="en-US" smtClean="0"/>
-              <a:t>6/25/2026</a:t>
+              <a:t>6/26/2026</a:t>
             </a:fld>
             <a:endParaRPr lang="en-US"/>
           </a:p>
@@ -1058,7 +1058,7 @@
           <a:p>
             <a:fld id="{68C2560D-EC28-3B41-86E8-18F1CE0113B4}" type="datetimeFigureOut">
               <a:rPr lang="en-US" smtClean="0"/>
-              <a:t>6/25/2026</a:t>
+              <a:t>6/26/2026</a:t>
             </a:fld>
             <a:endParaRPr lang="en-US"/>
           </a:p>
@@ -1285,7 +1285,7 @@
             <a:fld id="{4A9E7B99-7C3F-4BC3-B7B8-7E1F8C620B24}" type="datetime1">
               <a:rPr lang="en-US" smtClean="0"/>
               <a:pPr/>
-              <a:t>6/25/2026</a:t>
+              <a:t>6/26/2026</a:t>
             </a:fld>
             <a:endParaRPr lang="en-US"/>
           </a:p>
@@ -1552,7 +1552,7 @@
           <a:p>
             <a:fld id="{68C2560D-EC28-3B41-86E8-18F1CE0113B4}" type="datetimeFigureOut">
               <a:rPr lang="en-US" smtClean="0"/>
-              <a:t>6/25/2026</a:t>
+              <a:t>6/26/2026</a:t>
             </a:fld>
             <a:endParaRPr lang="en-US"/>
           </a:p>
@@ -1832,7 +1832,7 @@
           <a:p>
             <a:fld id="{68C2560D-EC28-3B41-86E8-18F1CE0113B4}" type="datetimeFigureOut">
               <a:rPr lang="en-US" smtClean="0"/>
-              <a:t>6/25/2026</a:t>
+              <a:t>6/26/2026</a:t>
             </a:fld>
             <a:endParaRPr lang="en-US"/>
           </a:p>
@@ -2081,7 +2081,7 @@
           <a:p>
             <a:fld id="{68C2560D-EC28-3B41-86E8-18F1CE0113B4}" type="datetimeFigureOut">
               <a:rPr lang="en-US" smtClean="0"/>
-              <a:t>6/25/2026</a:t>
+              <a:t>6/26/2026</a:t>
             </a:fld>
             <a:endParaRPr lang="en-US"/>
           </a:p>
@@ -2157,7 +2157,7 @@
           <a:p>
             <a:fld id="{68C2560D-EC28-3B41-86E8-18F1CE0113B4}" type="datetimeFigureOut">
               <a:rPr lang="en-US" smtClean="0"/>
-              <a:t>6/25/2026</a:t>
+              <a:t>6/26/2026</a:t>
             </a:fld>
             <a:endParaRPr lang="en-US"/>
           </a:p>
@@ -2413,7 +2413,7 @@
           <a:p>
             <a:fld id="{68C2560D-EC28-3B41-86E8-18F1CE0113B4}" type="datetimeFigureOut">
               <a:rPr lang="en-US" smtClean="0"/>
-              <a:t>6/25/2026</a:t>
+              <a:t>6/26/2026</a:t>
             </a:fld>
             <a:endParaRPr lang="en-US"/>
           </a:p>
@@ -2653,7 +2653,7 @@
           <a:p>
             <a:fld id="{68C2560D-EC28-3B41-86E8-18F1CE0113B4}" type="datetimeFigureOut">
               <a:rPr lang="en-US" smtClean="0"/>
-              <a:t>6/25/2026</a:t>
+              <a:t>6/26/2026</a:t>
             </a:fld>
             <a:endParaRPr lang="en-US"/>
           </a:p>
@@ -2954,7 +2954,7 @@
             <a:fld id="{68C2560D-EC28-3B41-86E8-18F1CE0113B4}" type="datetimeFigureOut">
               <a:rPr lang="en-US" smtClean="0"/>
               <a:pPr/>
-              <a:t>6/25/2026</a:t>
+              <a:t>6/26/2026</a:t>
             </a:fld>
             <a:endParaRPr lang="en-US" dirty="0"/>
           </a:p>
@@ -3455,14 +3455,20 @@
                 </a:solidFill>
                 <a:latin typeface="Calibri"/>
               </a:rPr>
-              <a:t>The Math: How Yelp Becomes Music</a:t>
+              <a:t>Math</a:t>
             </a:r>
           </a:p>
         </p:txBody>
       </p:sp>
       <p:pic>
         <p:nvPicPr>
-          <p:cNvPr id="3" name="Image 3"/>
+          <p:cNvPr id="7" name="Picture 6">
+            <a:extLst>
+              <a:ext uri="{FF2B5EF4-FFF2-40B4-BE49-F238E27FC236}">
+                <a16:creationId xmlns:a16="http://schemas.microsoft.com/office/drawing/2014/main" id="{7CE58B4D-075E-0995-7257-7D101BDCF00C}"/>
+              </a:ext>
+            </a:extLst>
+          </p:cNvPr>
           <p:cNvPicPr>
             <a:picLocks noChangeAspect="1"/>
           </p:cNvPicPr>
@@ -3476,8 +3482,8 @@
         </p:blipFill>
         <p:spPr>
           <a:xfrm>
-            <a:off x="1198217" y="1128491"/>
-            <a:ext cx="7344000" cy="3800000"/>
+            <a:off x="2043545" y="1418078"/>
+            <a:ext cx="5950527" cy="3005647"/>
           </a:xfrm>
           <a:prstGeom prst="rect">
             <a:avLst/>
@@ -4077,7 +4083,7 @@
         <p:spPr>
           <a:xfrm>
             <a:off x="1205345" y="907253"/>
-            <a:ext cx="6781799" cy="3093154"/>
+            <a:ext cx="6781799" cy="3693319"/>
           </a:xfrm>
           <a:prstGeom prst="rect">
             <a:avLst/>
@@ -4127,6 +4133,13 @@
           </a:p>
           <a:p>
             <a:pPr>
+              <a:buFont typeface="Arial" panose="020B0604020202020204" pitchFamily="34" charset="0"/>
+              <a:buChar char="•"/>
+            </a:pPr>
+            <a:endParaRPr lang="en-US" sz="1300" dirty="0"/>
+          </a:p>
+          <a:p>
+            <a:pPr>
               <a:buNone/>
             </a:pPr>
             <a:r>
@@ -4163,6 +4176,13 @@
           </a:p>
           <a:p>
             <a:pPr>
+              <a:buFont typeface="Arial" panose="020B0604020202020204" pitchFamily="34" charset="0"/>
+              <a:buChar char="•"/>
+            </a:pPr>
+            <a:endParaRPr lang="en-US" sz="1300" dirty="0"/>
+          </a:p>
+          <a:p>
+            <a:pPr>
               <a:buNone/>
             </a:pPr>
             <a:r>
@@ -4199,6 +4219,13 @@
           </a:p>
           <a:p>
             <a:pPr>
+              <a:buFont typeface="Arial" panose="020B0604020202020204" pitchFamily="34" charset="0"/>
+              <a:buChar char="•"/>
+            </a:pPr>
+            <a:endParaRPr lang="en-US" sz="1300" dirty="0"/>
+          </a:p>
+          <a:p>
+            <a:pPr>
               <a:buNone/>
             </a:pPr>
             <a:r>
@@ -4213,7 +4240,7 @@
             </a:pPr>
             <a:r>
               <a:rPr lang="en-US" sz="1300" dirty="0"/>
-              <a:t>Leftovers = Noise &amp; Constraints ( unpredictable delays, warehouse caps)</a:t>
+              <a:t>Leftovers = Noise &amp; Constraints </a:t>
             </a:r>
           </a:p>
           <a:p>
@@ -4223,7 +4250,7 @@
             </a:pPr>
             <a:r>
               <a:rPr lang="en-US" sz="1300" dirty="0"/>
-              <a:t>Captures physical limits and errors the model cannot explain</a:t>
+              <a:t>Identifies redundant observations </a:t>
             </a:r>
           </a:p>
         </p:txBody>
@@ -4322,7 +4349,7 @@
         </p:nvSpPr>
         <p:spPr>
           <a:xfrm>
-            <a:off x="1156855" y="1222950"/>
+            <a:off x="990600" y="890441"/>
             <a:ext cx="7629291" cy="3806250"/>
           </a:xfrm>
           <a:prstGeom prst="rect">
@@ -4332,179 +4359,112 @@
         </p:spPr>
         <p:txBody>
           <a:bodyPr wrap="square">
-            <a:normAutofit/>
+            <a:noAutofit/>
           </a:bodyPr>
           <a:lstStyle/>
           <a:p>
-            <a:pPr algn="l"/>
-            <a:r>
-              <a:rPr lang="en-US" sz="1450" b="0" dirty="0" err="1">
-                <a:solidFill>
-                  <a:srgbClr val="333333"/>
-                </a:solidFill>
-                <a:latin typeface="Calibri"/>
-              </a:rPr>
-              <a:t>RREf</a:t>
-            </a:r>
-            <a:r>
-              <a:rPr lang="en-US" sz="1450" b="0" dirty="0">
-                <a:solidFill>
-                  <a:srgbClr val="333333"/>
-                </a:solidFill>
-                <a:latin typeface="Calibri"/>
-              </a:rPr>
-              <a:t> identifies which columns are redundant </a:t>
-            </a:r>
-          </a:p>
-          <a:p>
-            <a:pPr algn="l"/>
-            <a:endParaRPr lang="en-US" sz="1450" b="0" dirty="0">
-              <a:solidFill>
-                <a:srgbClr val="333333"/>
-              </a:solidFill>
-              <a:latin typeface="Calibri"/>
-            </a:endParaRPr>
-          </a:p>
-          <a:p>
-            <a:pPr algn="l"/>
-            <a:r>
-              <a:rPr lang="en-US" sz="1450" dirty="0">
-                <a:solidFill>
-                  <a:srgbClr val="333333"/>
-                </a:solidFill>
-                <a:latin typeface="Calibri"/>
-              </a:rPr>
-              <a:t>PCA:</a:t>
-            </a:r>
-          </a:p>
-          <a:p>
-            <a:pPr algn="l"/>
-            <a:r>
-              <a:rPr lang="en-US" sz="1450" b="0" dirty="0" err="1">
-                <a:solidFill>
-                  <a:srgbClr val="333333"/>
-                </a:solidFill>
-                <a:latin typeface="Calibri"/>
-              </a:rPr>
-              <a:t>Eigionvalue</a:t>
-            </a:r>
-            <a:r>
-              <a:rPr lang="en-US" sz="1450" b="0" dirty="0">
-                <a:solidFill>
-                  <a:srgbClr val="333333"/>
-                </a:solidFill>
-                <a:latin typeface="Calibri"/>
-              </a:rPr>
-              <a:t> </a:t>
-            </a:r>
-          </a:p>
-          <a:p>
-            <a:pPr algn="l"/>
-            <a:r>
-              <a:rPr lang="en-US" sz="1450" dirty="0" err="1">
-                <a:solidFill>
-                  <a:srgbClr val="333333"/>
-                </a:solidFill>
-                <a:latin typeface="Calibri"/>
-              </a:rPr>
-              <a:t>Egionvectors</a:t>
-            </a:r>
-            <a:endParaRPr lang="en-US" sz="1450" b="0" dirty="0">
-              <a:solidFill>
-                <a:srgbClr val="333333"/>
-              </a:solidFill>
-              <a:latin typeface="Calibri"/>
-            </a:endParaRPr>
-          </a:p>
-          <a:p>
-            <a:pPr algn="l"/>
-            <a:endParaRPr lang="en-US" sz="1450" b="0" dirty="0">
-              <a:solidFill>
-                <a:srgbClr val="333333"/>
-              </a:solidFill>
-              <a:latin typeface="Calibri"/>
-            </a:endParaRPr>
-          </a:p>
-          <a:p>
-            <a:pPr algn="l"/>
-            <a:r>
-              <a:rPr lang="en-US" sz="1450" b="0" dirty="0" err="1">
-                <a:solidFill>
-                  <a:srgbClr val="333333"/>
-                </a:solidFill>
-                <a:latin typeface="Calibri"/>
-              </a:rPr>
+            <a:r>
+              <a:rPr lang="en-US" sz="1300" b="1" dirty="0"/>
+              <a:t>Matrix Factorization</a:t>
+            </a:r>
+          </a:p>
+          <a:p>
+            <a:r>
+              <a:rPr lang="en-US" sz="1300" dirty="0"/>
+              <a:t>LU Decomposition (A = LU): Factoring a matrix into Lower and Upper triangular components to record the steps of Gaussian elimination.</a:t>
+            </a:r>
+          </a:p>
+          <a:p>
+            <a:endParaRPr lang="en-US" sz="1300" dirty="0"/>
+          </a:p>
+          <a:p>
+            <a:endParaRPr lang="en-US" sz="1300" dirty="0"/>
+          </a:p>
+          <a:p>
+            <a:r>
+              <a:rPr lang="en-US" sz="1300" b="1" dirty="0"/>
+              <a:t>PCA</a:t>
+            </a:r>
+          </a:p>
+          <a:p>
+            <a:r>
+              <a:rPr lang="en-US" sz="1300" b="1" dirty="0"/>
+              <a:t>Eigenvectors: </a:t>
+            </a:r>
+            <a:r>
+              <a:rPr lang="en-US" sz="1300" dirty="0"/>
+              <a:t>Direction of the variance of the dataset</a:t>
+            </a:r>
+          </a:p>
+          <a:p>
+            <a:r>
+              <a:rPr lang="en-US" sz="1300" b="1" dirty="0"/>
+              <a:t>Eigenvalues:</a:t>
+            </a:r>
+            <a:r>
+              <a:rPr lang="en-US" sz="1300" dirty="0"/>
+              <a:t>  Magnitude / importance of the direction</a:t>
+            </a:r>
+          </a:p>
+          <a:p>
+            <a:endParaRPr lang="en-US" sz="1300" dirty="0"/>
+          </a:p>
+          <a:p>
+            <a:endParaRPr lang="en-US" sz="1300" dirty="0"/>
+          </a:p>
+          <a:p>
+            <a:r>
+              <a:rPr lang="en-US" sz="1300" b="1" dirty="0" err="1"/>
               <a:t>StandardScaler</a:t>
             </a:r>
-            <a:endParaRPr lang="en-US" sz="1450" b="0" dirty="0">
-              <a:solidFill>
-                <a:srgbClr val="333333"/>
-              </a:solidFill>
-              <a:latin typeface="Calibri"/>
-            </a:endParaRPr>
-          </a:p>
-          <a:p>
-            <a:pPr algn="l"/>
-            <a:r>
-              <a:rPr lang="en-US" sz="1450" b="0" dirty="0">
-                <a:solidFill>
-                  <a:srgbClr val="333333"/>
-                </a:solidFill>
-                <a:latin typeface="Calibri"/>
-              </a:rPr>
-              <a:t> used before PCA so variance-</a:t>
-            </a:r>
-          </a:p>
-          <a:p>
-            <a:pPr algn="l"/>
-            <a:r>
-              <a:rPr lang="en-US" sz="1450" b="0" dirty="0">
-                <a:solidFill>
-                  <a:srgbClr val="333333"/>
-                </a:solidFill>
-                <a:latin typeface="Calibri"/>
-              </a:rPr>
-              <a:t>based math is not distorted by unit differences.</a:t>
-            </a:r>
-          </a:p>
-          <a:p>
-            <a:pPr algn="l"/>
-            <a:endParaRPr lang="en-US" sz="1450" dirty="0">
-              <a:solidFill>
-                <a:srgbClr val="333333"/>
-              </a:solidFill>
-              <a:latin typeface="Calibri"/>
-            </a:endParaRPr>
-          </a:p>
-          <a:p>
-            <a:pPr algn="l"/>
-            <a:r>
-              <a:rPr lang="en-US" sz="1450" b="0" dirty="0">
-                <a:solidFill>
-                  <a:srgbClr val="333333"/>
-                </a:solidFill>
-                <a:latin typeface="Calibri"/>
-              </a:rPr>
-              <a:t>Wh</a:t>
-            </a:r>
-            <a:r>
-              <a:rPr lang="en-US" sz="1450" dirty="0">
-                <a:solidFill>
-                  <a:srgbClr val="333333"/>
-                </a:solidFill>
-                <a:latin typeface="Calibri"/>
-              </a:rPr>
-              <a:t>y Transpose</a:t>
-            </a:r>
-          </a:p>
-          <a:p>
-            <a:pPr algn="l"/>
-            <a:endParaRPr lang="en-US" sz="1450" b="0" dirty="0">
-              <a:solidFill>
-                <a:srgbClr val="333333"/>
-              </a:solidFill>
-              <a:latin typeface="Calibri"/>
-            </a:endParaRPr>
+            <a:endParaRPr lang="en-US" sz="1300" b="1" dirty="0"/>
+          </a:p>
+          <a:p>
+            <a:r>
+              <a:rPr lang="en-US" sz="1300" dirty="0"/>
+              <a:t>Neutralize unit differences (Km vs Cm)</a:t>
+            </a:r>
+          </a:p>
+          <a:p>
+            <a:endParaRPr lang="en-US" sz="1300" dirty="0"/>
+          </a:p>
+          <a:p>
+            <a:endParaRPr lang="en-US" sz="1300" dirty="0"/>
+          </a:p>
+          <a:p>
+            <a:r>
+              <a:rPr lang="en-US" sz="1300" b="1" dirty="0"/>
+              <a:t>Matrix Transpose</a:t>
+            </a:r>
+          </a:p>
+          <a:p>
+            <a:r>
+              <a:rPr lang="en-US" sz="1300" dirty="0"/>
+              <a:t>A step to calculate covariance matrices and shift operations between features and observations.</a:t>
+            </a:r>
+          </a:p>
+          <a:p>
+            <a:endParaRPr lang="en-US" sz="1300" dirty="0"/>
+          </a:p>
+          <a:p>
+            <a:endParaRPr lang="en-US" sz="1300" dirty="0"/>
+          </a:p>
+          <a:p>
+            <a:r>
+              <a:rPr lang="en-US" sz="1300" b="1" dirty="0"/>
+              <a:t>Orthogonality (</a:t>
+            </a:r>
+            <a:r>
+              <a:rPr lang="en-US" sz="1300" dirty="0"/>
+              <a:t>90-degree angle)</a:t>
+            </a:r>
+            <a:endParaRPr lang="en-US" sz="1300" b="1" dirty="0"/>
+          </a:p>
+          <a:p>
+            <a:r>
+              <a:rPr lang="en-US" sz="1300" dirty="0"/>
+              <a:t>To make sure new dimensions capture only unique information without introducing new redundancies.</a:t>
+            </a:r>
           </a:p>
         </p:txBody>
       </p:sp>
@@ -4736,42 +4696,6 @@
           </a:p>
           <a:p>
             <a:pPr algn="l"/>
-            <a:r>
-              <a:rPr lang="en-US" sz="1300" b="0" dirty="0">
-                <a:solidFill>
-                  <a:srgbClr val="333333"/>
-                </a:solidFill>
-                <a:latin typeface="Calibri"/>
-              </a:rPr>
-              <a:t>The null space confirms it: certain feature</a:t>
-            </a:r>
-          </a:p>
-          <a:p>
-            <a:pPr algn="l"/>
-            <a:r>
-              <a:rPr lang="en-US" sz="1300" b="0" dirty="0">
-                <a:solidFill>
-                  <a:srgbClr val="333333"/>
-                </a:solidFill>
-                <a:latin typeface="Calibri"/>
-              </a:rPr>
-              <a:t>combinations collapse to zero, they carry the</a:t>
-            </a:r>
-          </a:p>
-          <a:p>
-            <a:pPr algn="l"/>
-            <a:r>
-              <a:rPr lang="en-US" sz="1300" b="0" dirty="0">
-                <a:solidFill>
-                  <a:srgbClr val="333333"/>
-                </a:solidFill>
-                <a:latin typeface="Calibri"/>
-              </a:rPr>
-              <a:t>same information in different units.</a:t>
-            </a:r>
-          </a:p>
-          <a:p>
-            <a:pPr algn="l"/>
             <a:endParaRPr lang="en-US" sz="1300" b="0" dirty="0">
               <a:solidFill>
                 <a:srgbClr val="333333"/>
@@ -4942,10 +4866,10 @@
       </p:sp>
       <p:pic>
         <p:nvPicPr>
-          <p:cNvPr id="7" name="Picture 6">
+          <p:cNvPr id="9" name="Picture 8">
             <a:extLst>
               <a:ext uri="{FF2B5EF4-FFF2-40B4-BE49-F238E27FC236}">
-                <a16:creationId xmlns:a16="http://schemas.microsoft.com/office/drawing/2014/main" id="{9B688141-F041-AF2D-B0EE-9FD0610739E7}"/>
+                <a16:creationId xmlns:a16="http://schemas.microsoft.com/office/drawing/2014/main" id="{ACEB6270-3B84-976A-4AF4-016F73B44BFF}"/>
               </a:ext>
             </a:extLst>
           </p:cNvPr>
@@ -4962,8 +4886,8 @@
         </p:blipFill>
         <p:spPr>
           <a:xfrm>
-            <a:off x="1504746" y="1080000"/>
-            <a:ext cx="5902036" cy="2719832"/>
+            <a:off x="1654209" y="1139512"/>
+            <a:ext cx="6062890" cy="2726038"/>
           </a:xfrm>
           <a:prstGeom prst="rect">
             <a:avLst/>
@@ -5535,7 +5459,7 @@
         </p:nvSpPr>
         <p:spPr>
           <a:xfrm>
-            <a:off x="1086600" y="1960000"/>
+            <a:off x="1174310" y="1967618"/>
             <a:ext cx="1370000" cy="1900000"/>
           </a:xfrm>
           <a:prstGeom prst="rect">
@@ -5557,7 +5481,7 @@
                 </a:solidFill>
                 <a:latin typeface="Calibri"/>
               </a:rPr>
-              <a:t>Manually pair restaurants to target audio profiles</a:t>
+              <a:t>Manually pair restaurants to target audio</a:t>
             </a:r>
           </a:p>
           <a:p>
@@ -5637,13 +5561,22 @@
           <a:p>
             <a:pPr algn="l"/>
             <a:r>
+              <a:rPr lang="en-US" sz="1300" dirty="0">
+                <a:solidFill>
+                  <a:srgbClr val="333333"/>
+                </a:solidFill>
+                <a:latin typeface="Calibri"/>
+              </a:rPr>
+              <a:t>F</a:t>
+            </a:r>
+            <a:r>
               <a:rPr lang="en-US" sz="1300" b="0" dirty="0">
                 <a:solidFill>
                   <a:srgbClr val="333333"/>
                 </a:solidFill>
                 <a:latin typeface="Calibri"/>
               </a:rPr>
-              <a:t>Ordinary Least Squares: find W minimizing error</a:t>
+              <a:t>ind W minimizing error</a:t>
             </a:r>
           </a:p>
           <a:p>
@@ -5655,7 +5588,7 @@
                 </a:solidFill>
                 <a:latin typeface="Calibri"/>
               </a:rPr>
-              <a:t>between predicted and curated song profiles</a:t>
+              <a:t>between predicted and recommended song</a:t>
             </a:r>
           </a:p>
         </p:txBody>
@@ -5732,18 +5665,6 @@
               <a:t>W ⋅ (Yelp PCA vector) = target Spotify audio profile</a:t>
             </a:r>
           </a:p>
-          <a:p>
-            <a:pPr algn="l"/>
-            <a:r>
-              <a:rPr lang="en-US" sz="1300" b="0" dirty="0">
-                <a:solidFill>
-                  <a:srgbClr val="333333"/>
-                </a:solidFill>
-                <a:latin typeface="Calibri"/>
-              </a:rPr>
-              <a:t>Now both datasets speak the same language</a:t>
-            </a:r>
-          </a:p>
         </p:txBody>
       </p:sp>
       <p:sp>
@@ -5815,7 +5736,7 @@
                 </a:solidFill>
                 <a:latin typeface="Calibri"/>
               </a:rPr>
-              <a:t>Search all 1.2M Spotify tracks for vectors</a:t>
+              <a:t>Search songs for vectors</a:t>
             </a:r>
           </a:p>
           <a:p>
@@ -5827,7 +5748,7 @@
                 </a:solidFill>
                 <a:latin typeface="Calibri"/>
               </a:rPr>
-              <a:t>closest in angle to the predicted target profile</a:t>
+              <a:t>closest in angle to the predicted target</a:t>
             </a:r>
           </a:p>
         </p:txBody>
@@ -5901,19 +5822,7 @@
                 </a:solidFill>
                 <a:latin typeface="Calibri"/>
               </a:rPr>
-              <a:t>Thumbs up/down refines W over time</a:t>
-            </a:r>
-          </a:p>
-          <a:p>
-            <a:pPr algn="l"/>
-            <a:r>
-              <a:rPr lang="en-US" sz="1300" b="0" dirty="0">
-                <a:solidFill>
-                  <a:srgbClr val="333333"/>
-                </a:solidFill>
-                <a:latin typeface="Calibri"/>
-              </a:rPr>
-              <a:t>Active learning makes the model smarter</a:t>
+              <a:t>Human feedback tune the weights.</a:t>
             </a:r>
           </a:p>
         </p:txBody>
@@ -6247,6 +6156,15 @@
 </file>
 
 <file path=customXml/item1.xml><?xml version="1.0" encoding="utf-8"?>
+<?mso-contentType ?>
+<FormTemplates xmlns="http://schemas.microsoft.com/sharepoint/v3/contenttype/forms">
+  <Display>DocumentLibraryForm</Display>
+  <Edit>DocumentLibraryForm</Edit>
+  <New>DocumentLibraryForm</New>
+</FormTemplates>
+</file>
+
+<file path=customXml/item2.xml><?xml version="1.0" encoding="utf-8"?>
 <ct:contentTypeSchema xmlns:ct="http://schemas.microsoft.com/office/2006/metadata/contentType" xmlns:ma="http://schemas.microsoft.com/office/2006/metadata/properties/metaAttributes" ct:_="" ma:_="" ma:contentTypeName="Document" ma:contentTypeID="0x0101000DE64AEEDD9B7A4D93545ACBE97D4615" ma:contentTypeVersion="2" ma:contentTypeDescription="Create a new document." ma:contentTypeScope="" ma:versionID="f49002b78e3a4a71b814eef46a983816">
   <xsd:schema xmlns:xsd="http://www.w3.org/2001/XMLSchema" xmlns:xs="http://www.w3.org/2001/XMLSchema" xmlns:p="http://schemas.microsoft.com/office/2006/metadata/properties" xmlns:ns2="http://schemas.microsoft.com/sharepoint/v3/fields" targetNamespace="http://schemas.microsoft.com/office/2006/metadata/properties" ma:root="true" ma:fieldsID="38f6db2dd0d9a0cf6a8dc37be32b365b" ns2:_="">
     <xsd:import namespace="http://schemas.microsoft.com/sharepoint/v3/fields"/>
@@ -6390,15 +6308,6 @@
 </ct:contentTypeSchema>
 </file>
 
-<file path=customXml/item2.xml><?xml version="1.0" encoding="utf-8"?>
-<?mso-contentType ?>
-<FormTemplates xmlns="http://schemas.microsoft.com/sharepoint/v3/contenttype/forms">
-  <Display>DocumentLibraryForm</Display>
-  <Edit>DocumentLibraryForm</Edit>
-  <New>DocumentLibraryForm</New>
-</FormTemplates>
-</file>
-
 <file path=customXml/item3.xml><?xml version="1.0" encoding="utf-8"?>
 <p:properties xmlns:p="http://schemas.microsoft.com/office/2006/metadata/properties" xmlns:xsi="http://www.w3.org/2001/XMLSchema-instance" xmlns:pc="http://schemas.microsoft.com/office/infopath/2007/PartnerControls">
   <documentManagement>
@@ -6409,6 +6318,14 @@
 </file>
 
 <file path=customXml/itemProps1.xml><?xml version="1.0" encoding="utf-8"?>
+<ds:datastoreItem xmlns:ds="http://schemas.openxmlformats.org/officeDocument/2006/customXml" ds:itemID="{87D2A1B0-FF3E-4009-940D-AED0EB70AA20}">
+  <ds:schemaRefs>
+    <ds:schemaRef ds:uri="http://schemas.microsoft.com/sharepoint/v3/contenttype/forms"/>
+  </ds:schemaRefs>
+</ds:datastoreItem>
+</file>
+
+<file path=customXml/itemProps2.xml><?xml version="1.0" encoding="utf-8"?>
 <ds:datastoreItem xmlns:ds="http://schemas.openxmlformats.org/officeDocument/2006/customXml" ds:itemID="{E4214858-785C-42F7-BE66-6D0E79395FC8}">
   <ds:schemaRefs>
     <ds:schemaRef ds:uri="http://schemas.microsoft.com/office/2006/metadata/contentType"/>
@@ -6426,14 +6343,6 @@
 </ds:datastoreItem>
 </file>
 
-<file path=customXml/itemProps2.xml><?xml version="1.0" encoding="utf-8"?>
-<ds:datastoreItem xmlns:ds="http://schemas.openxmlformats.org/officeDocument/2006/customXml" ds:itemID="{87D2A1B0-FF3E-4009-940D-AED0EB70AA20}">
-  <ds:schemaRefs>
-    <ds:schemaRef ds:uri="http://schemas.microsoft.com/sharepoint/v3/contenttype/forms"/>
-  </ds:schemaRefs>
-</ds:datastoreItem>
-</file>
-
 <file path=customXml/itemProps3.xml><?xml version="1.0" encoding="utf-8"?>
 <ds:datastoreItem xmlns:ds="http://schemas.openxmlformats.org/officeDocument/2006/customXml" ds:itemID="{7B6F2769-7194-4217-93D3-3AF3A4742282}">
   <ds:schemaRefs>

</xml_diff>